<commit_message>
presentation/docs: clarify qualitative vs quantitative verification
\"precision/recall не измерены\" read as if no verification happened at
all, when in fact all 3 real documents were manually read and checked -
just not turned into a numeric score (needs a labeled ground-truth
sample we don't have from NET). Reworded the slide 9 bullet and the
matching limitations line in project-description-final.md to say this
explicitly, instead of leaving it ambiguous.

Co-Authored-By: Claude Sonnet 5 <noreply@anthropic.com>
</commit_message>
<xml_diff>
--- a/presentation/ТЗ-Ревьюер — финальная защита.pptx
+++ b/presentation/ТЗ-Ревьюер — финальная защита.pptx
@@ -9947,7 +9947,7 @@
                 <a:ea typeface="Calibri" pitchFamily="34" charset="-122"/>
                 <a:cs typeface="Calibri" pitchFamily="34" charset="-120"/>
               </a:rPr>
-              <a:t>ОСТАЁТСЯ РИСКОМ / НЕ ИЗМЕРЕНО</a:t>
+              <a:t>ПРОВЕРЕНО КАЧЕСТВЕННО, НЕ В ЦИФРАХ</a:t>
             </a:r>
             <a:endParaRPr lang="en-US" sz="1200" dirty="0"/>
           </a:p>
@@ -9978,16 +9978,16 @@
           <a:p>
             <a:pPr marL="152400" indent="-152400">
               <a:lnSpc>
-                <a:spcPct val="100000"/>
+                <a:spcPct val="108000"/>
               </a:lnSpc>
               <a:spcAft>
-                <a:spcPts val="1100"/>
+                <a:spcPts val="1000"/>
               </a:spcAft>
               <a:buSzPct val="100000"/>
               <a:buChar char="•"/>
             </a:pPr>
             <a:r>
-              <a:rPr lang="en-US" sz="1250" dirty="0">
+              <a:rPr lang="en-US" sz="1100" dirty="0">
                 <a:solidFill>
                   <a:srgbClr val="1E3252"/>
                 </a:solidFill>
@@ -9995,23 +9995,23 @@
                 <a:ea typeface="Calibri" pitchFamily="34" charset="-122"/>
                 <a:cs typeface="Calibri" pitchFamily="34" charset="-120"/>
               </a:rPr>
-              <a:t>нет пост-проверки, что цитата дословно есть в тексте;</a:t>
-            </a:r>
-            <a:endParaRPr lang="en-US" sz="1250" dirty="0"/>
+              <a:t>качество замечаний оценено вручную (эксперт прочитал все отчёты) — не переведено в precision/recall, для этого нужна разметка эталонных находок;</a:t>
+            </a:r>
+            <a:endParaRPr lang="en-US" sz="1100" dirty="0"/>
           </a:p>
           <a:p>
             <a:pPr marL="152400" indent="-152400">
               <a:lnSpc>
-                <a:spcPct val="100000"/>
+                <a:spcPct val="108000"/>
               </a:lnSpc>
               <a:spcAft>
-                <a:spcPts val="1100"/>
+                <a:spcPts val="1000"/>
               </a:spcAft>
               <a:buSzPct val="100000"/>
               <a:buChar char="•"/>
             </a:pPr>
             <a:r>
-              <a:rPr lang="en-US" sz="1250" dirty="0">
+              <a:rPr lang="en-US" sz="1100" dirty="0">
                 <a:solidFill>
                   <a:srgbClr val="1E3252"/>
                 </a:solidFill>
@@ -10019,23 +10019,23 @@
                 <a:ea typeface="Calibri" pitchFamily="34" charset="-122"/>
                 <a:cs typeface="Calibri" pitchFamily="34" charset="-120"/>
               </a:rPr>
-              <a:t>precision/recall не измерены на размеченной выборке;</a:t>
-            </a:r>
-            <a:endParaRPr lang="en-US" sz="1250" dirty="0"/>
+              <a:t>нет пост-проверки, что цитата дословно есть в тексте (пока — визуальная сверка);</a:t>
+            </a:r>
+            <a:endParaRPr lang="en-US" sz="1100" dirty="0"/>
           </a:p>
           <a:p>
             <a:pPr marL="152400" indent="-152400">
               <a:lnSpc>
-                <a:spcPct val="100000"/>
+                <a:spcPct val="108000"/>
               </a:lnSpc>
               <a:spcAft>
-                <a:spcPts val="1100"/>
+                <a:spcPts val="1000"/>
               </a:spcAft>
               <a:buSzPct val="100000"/>
               <a:buChar char="•"/>
             </a:pPr>
             <a:r>
-              <a:rPr lang="en-US" sz="1250" dirty="0">
+              <a:rPr lang="en-US" sz="1100" dirty="0">
                 <a:solidFill>
                   <a:srgbClr val="1E3252"/>
                 </a:solidFill>
@@ -10043,9 +10043,9 @@
                 <a:ea typeface="Calibri" pitchFamily="34" charset="-122"/>
                 <a:cs typeface="Calibri" pitchFamily="34" charset="-120"/>
               </a:rPr>
-              <a:t>few-shot построен на обобщённом опыте, не на реальных правках NET.</a:t>
-            </a:r>
-            <a:endParaRPr lang="en-US" sz="1250" dirty="0"/>
+              <a:t>few-shot построен на обобщённом опыте, не на реальных правках NET — их ещё предстоит получить.</a:t>
+            </a:r>
+            <a:endParaRPr lang="en-US" sz="1100" dirty="0"/>
           </a:p>
         </p:txBody>
       </p:sp>

</xml_diff>

<commit_message>
presentation/docs: credit the coverage rework in the team split
The team slide and description undersold Фырат's final-phase work:
the 5-state template-coverage model, structural gaps surfaced as
findings, the Streamlit result-persistence fix, the extended test
suite, and the critical LLM-output review. Updated both to reflect
actual participation, as the case asks for.

Co-Authored-By: Claude Sonnet 5 <noreply@anthropic.com>
</commit_message>
<xml_diff>
--- a/presentation/ТЗ-Ревьюер — финальная защита.pptx
+++ b/presentation/ТЗ-Ревьюер — финальная защита.pptx
@@ -3190,8 +3190,8 @@
         </p:nvSpPr>
         <p:spPr>
           <a:xfrm>
-            <a:off x="777240" y="2788920"/>
-            <a:ext cx="4846320" cy="2743200"/>
+            <a:off x="777240" y="2761488"/>
+            <a:ext cx="4846320" cy="2788920"/>
           </a:xfrm>
           <a:prstGeom prst="rect">
             <a:avLst/>
@@ -3207,16 +3207,16 @@
           <a:p>
             <a:pPr marL="152400" indent="-152400">
               <a:lnSpc>
-                <a:spcPct val="112000"/>
+                <a:spcPct val="110000"/>
               </a:lnSpc>
               <a:spcAft>
-                <a:spcPts val="1100"/>
+                <a:spcPts val="800"/>
               </a:spcAft>
               <a:buSzPct val="100000"/>
               <a:buChar char="•"/>
             </a:pPr>
             <a:r>
-              <a:rPr lang="en-US" sz="1200" dirty="0">
+              <a:rPr lang="en-US" sz="1050" dirty="0">
                 <a:solidFill>
                   <a:srgbClr val="1E3252"/>
                 </a:solidFill>
@@ -3226,21 +3226,21 @@
               </a:rPr>
               <a:t>рубрика ревью (23 категории) и промпты, включая интеграцию официальных критериев МТС</a:t>
             </a:r>
-            <a:endParaRPr lang="en-US" sz="1200" dirty="0"/>
+            <a:endParaRPr lang="en-US" sz="1050" dirty="0"/>
           </a:p>
           <a:p>
             <a:pPr marL="152400" indent="-152400">
               <a:lnSpc>
-                <a:spcPct val="112000"/>
+                <a:spcPct val="110000"/>
               </a:lnSpc>
               <a:spcAft>
-                <a:spcPts val="1100"/>
+                <a:spcPts val="800"/>
               </a:spcAft>
               <a:buSzPct val="100000"/>
               <a:buChar char="•"/>
             </a:pPr>
             <a:r>
-              <a:rPr lang="en-US" sz="1200" dirty="0">
+              <a:rPr lang="en-US" sz="1050" dirty="0">
                 <a:solidFill>
                   <a:srgbClr val="1E3252"/>
                 </a:solidFill>
@@ -3250,21 +3250,21 @@
               </a:rPr>
               <a:t>структурированный вывод и сборка отчёта</a:t>
             </a:r>
-            <a:endParaRPr lang="en-US" sz="1200" dirty="0"/>
+            <a:endParaRPr lang="en-US" sz="1050" dirty="0"/>
           </a:p>
           <a:p>
             <a:pPr marL="152400" indent="-152400">
               <a:lnSpc>
-                <a:spcPct val="112000"/>
+                <a:spcPct val="110000"/>
               </a:lnSpc>
               <a:spcAft>
-                <a:spcPts val="1100"/>
+                <a:spcPts val="800"/>
               </a:spcAft>
               <a:buSzPct val="100000"/>
               <a:buChar char="•"/>
             </a:pPr>
             <a:r>
-              <a:rPr lang="en-US" sz="1200" dirty="0">
+              <a:rPr lang="en-US" sz="1050" dirty="0">
                 <a:solidFill>
                   <a:srgbClr val="1E3252"/>
                 </a:solidFill>
@@ -3274,21 +3274,21 @@
               </a:rPr>
               <a:t>тестирование на 3 реальных документах в офлайн- и LLM-режиме, диагностика и исправление найденных багов</a:t>
             </a:r>
-            <a:endParaRPr lang="en-US" sz="1200" dirty="0"/>
+            <a:endParaRPr lang="en-US" sz="1050" dirty="0"/>
           </a:p>
           <a:p>
             <a:pPr marL="152400" indent="-152400">
               <a:lnSpc>
-                <a:spcPct val="112000"/>
+                <a:spcPct val="110000"/>
               </a:lnSpc>
               <a:spcAft>
-                <a:spcPts val="1100"/>
+                <a:spcPts val="800"/>
               </a:spcAft>
               <a:buSzPct val="100000"/>
               <a:buChar char="•"/>
             </a:pPr>
             <a:r>
-              <a:rPr lang="en-US" sz="1200" dirty="0">
+              <a:rPr lang="en-US" sz="1050" dirty="0">
                 <a:solidFill>
                   <a:srgbClr val="1E3252"/>
                 </a:solidFill>
@@ -3298,7 +3298,7 @@
               </a:rPr>
               <a:t>проектная документация и презентация</a:t>
             </a:r>
-            <a:endParaRPr lang="en-US" sz="1200" dirty="0"/>
+            <a:endParaRPr lang="en-US" sz="1050" dirty="0"/>
           </a:p>
         </p:txBody>
       </p:sp>
@@ -3422,8 +3422,8 @@
         </p:nvSpPr>
         <p:spPr>
           <a:xfrm>
-            <a:off x="6537960" y="2788920"/>
-            <a:ext cx="4846320" cy="2743200"/>
+            <a:off x="6537960" y="2761488"/>
+            <a:ext cx="4846320" cy="2788920"/>
           </a:xfrm>
           <a:prstGeom prst="rect">
             <a:avLst/>
@@ -3439,16 +3439,16 @@
           <a:p>
             <a:pPr marL="152400" indent="-152400">
               <a:lnSpc>
-                <a:spcPct val="112000"/>
+                <a:spcPct val="110000"/>
               </a:lnSpc>
               <a:spcAft>
-                <a:spcPts val="1100"/>
+                <a:spcPts val="800"/>
               </a:spcAft>
               <a:buSzPct val="100000"/>
               <a:buChar char="•"/>
             </a:pPr>
             <a:r>
-              <a:rPr lang="en-US" sz="1200" dirty="0">
+              <a:rPr lang="en-US" sz="1050" dirty="0">
                 <a:solidFill>
                   <a:srgbClr val="1E3252"/>
                 </a:solidFill>
@@ -3456,23 +3456,23 @@
                 <a:ea typeface="Calibri" pitchFamily="34" charset="-122"/>
                 <a:cs typeface="Calibri" pitchFamily="34" charset="-120"/>
               </a:rPr>
-              <a:t>архитектура решения и сборка MVP</a:t>
-            </a:r>
-            <a:endParaRPr lang="en-US" sz="1200" dirty="0"/>
+              <a:t>архитектура решения, сборка MVP, провайдер-независимый клиент LLM</a:t>
+            </a:r>
+            <a:endParaRPr lang="en-US" sz="1050" dirty="0"/>
           </a:p>
           <a:p>
             <a:pPr marL="152400" indent="-152400">
               <a:lnSpc>
-                <a:spcPct val="112000"/>
+                <a:spcPct val="110000"/>
               </a:lnSpc>
               <a:spcAft>
-                <a:spcPts val="1100"/>
+                <a:spcPts val="800"/>
               </a:spcAft>
               <a:buSzPct val="100000"/>
               <a:buChar char="•"/>
             </a:pPr>
             <a:r>
-              <a:rPr lang="en-US" sz="1200" dirty="0">
+              <a:rPr lang="en-US" sz="1050" dirty="0">
                 <a:solidFill>
                   <a:srgbClr val="1E3252"/>
                 </a:solidFill>
@@ -3480,23 +3480,23 @@
                 <a:ea typeface="Calibri" pitchFamily="34" charset="-122"/>
                 <a:cs typeface="Calibri" pitchFamily="34" charset="-120"/>
               </a:rPr>
-              <a:t>разбор документа, первая версия эвристик и проверки шаблона</a:t>
-            </a:r>
-            <a:endParaRPr lang="en-US" sz="1200" dirty="0"/>
+              <a:t>разбор документа: иерархия разделов, таблицы и ссылки из .docx</a:t>
+            </a:r>
+            <a:endParaRPr lang="en-US" sz="1050" dirty="0"/>
           </a:p>
           <a:p>
             <a:pPr marL="152400" indent="-152400">
               <a:lnSpc>
-                <a:spcPct val="112000"/>
+                <a:spcPct val="110000"/>
               </a:lnSpc>
               <a:spcAft>
-                <a:spcPts val="1100"/>
+                <a:spcPts val="800"/>
               </a:spcAft>
               <a:buSzPct val="100000"/>
               <a:buChar char="•"/>
             </a:pPr>
             <a:r>
-              <a:rPr lang="en-US" sz="1200" dirty="0">
+              <a:rPr lang="en-US" sz="1050" dirty="0">
                 <a:solidFill>
                   <a:srgbClr val="1E3252"/>
                 </a:solidFill>
@@ -3504,23 +3504,23 @@
                 <a:ea typeface="Calibri" pitchFamily="34" charset="-122"/>
                 <a:cs typeface="Calibri" pitchFamily="34" charset="-120"/>
               </a:rPr>
-              <a:t>провайдер-независимый клиент LLM</a:t>
-            </a:r>
-            <a:endParaRPr lang="en-US" sz="1200" dirty="0"/>
+              <a:t>проверка покрытия шаблона: 5 статусов раздела (заполнен / пустой / не применимо / упомянут / нет), структурные пробелы как отдельные замечания</a:t>
+            </a:r>
+            <a:endParaRPr lang="en-US" sz="1050" dirty="0"/>
           </a:p>
           <a:p>
             <a:pPr marL="152400" indent="-152400">
               <a:lnSpc>
-                <a:spcPct val="112000"/>
+                <a:spcPct val="110000"/>
               </a:lnSpc>
               <a:spcAft>
-                <a:spcPts val="1100"/>
+                <a:spcPts val="800"/>
               </a:spcAft>
               <a:buSzPct val="100000"/>
               <a:buChar char="•"/>
             </a:pPr>
             <a:r>
-              <a:rPr lang="en-US" sz="1200" dirty="0">
+              <a:rPr lang="en-US" sz="1050" dirty="0">
                 <a:solidFill>
                   <a:srgbClr val="1E3252"/>
                 </a:solidFill>
@@ -3528,9 +3528,33 @@
                 <a:ea typeface="Calibri" pitchFamily="34" charset="-122"/>
                 <a:cs typeface="Calibri" pitchFamily="34" charset="-120"/>
               </a:rPr>
-              <a:t>независимое развёртывание и полный прогон проекта с нуля на отдельной машине (проверка воспроизводимости)</a:t>
-            </a:r>
-            <a:endParaRPr lang="en-US" sz="1200" dirty="0"/>
+              <a:t>устойчивость демо (сохранение результата в Streamlit) и расширенный набор автотестов</a:t>
+            </a:r>
+            <a:endParaRPr lang="en-US" sz="1050" dirty="0"/>
+          </a:p>
+          <a:p>
+            <a:pPr marL="152400" indent="-152400">
+              <a:lnSpc>
+                <a:spcPct val="110000"/>
+              </a:lnSpc>
+              <a:spcAft>
+                <a:spcPts val="800"/>
+              </a:spcAft>
+              <a:buSzPct val="100000"/>
+              <a:buChar char="•"/>
+            </a:pPr>
+            <a:r>
+              <a:rPr lang="en-US" sz="1050" dirty="0">
+                <a:solidFill>
+                  <a:srgbClr val="1E3252"/>
+                </a:solidFill>
+                <a:latin typeface="Calibri" pitchFamily="34" charset="0"/>
+                <a:ea typeface="Calibri" pitchFamily="34" charset="-122"/>
+                <a:cs typeface="Calibri" pitchFamily="34" charset="-120"/>
+              </a:rPr>
+              <a:t>независимый прогон проекта с нуля на отдельной машине + критическое ревью качества LLM-выдачи</a:t>
+            </a:r>
+            <a:endParaRPr lang="en-US" sz="1050" dirty="0"/>
           </a:p>
         </p:txBody>
       </p:sp>

</xml_diff>

<commit_message>
deck: enlarge slide 6 output screenshot for readability
Jury feedback: the embedded output screenshot on slide 6 was ~2.5in
wide and unreadable. Replaced the tall full-report crop with a
focused 2:1 landscape crop (report header + one finding card, larger
font) and restructured the slide: 3 compact document pills + one
context line on top, then a centered ~8in-wide screenshot that reads
clearly when projected.

Co-Authored-By: Claude Sonnet 5 <noreply@anthropic.com>
</commit_message>
<xml_diff>
--- a/presentation/ТЗ-Ревьюер — финальная защита.pptx
+++ b/presentation/ТЗ-Ревьюер — финальная защита.pptx
@@ -1128,7 +1128,7 @@
           <a:p>
             <a:r>
               <a:rPr lang="en-US" dirty="0"/>
-              <a:t>Скриншот — настоящий HTML-отчёт инструмента (cli.py --format html), не макет. LLM-режим на этих же документах нашёл более глубокие содержательные проблемы — см. следующий слайд.</a:t>
+              <a:t>Скриншот — настоящий HTML-отчёт инструмента (cli.py --format html), не макет. Показан офлайн-режим на реальном документе кейсодателя. LLM-режим на этих же документах нашёл более глубокие содержательные проблемы — см. следующий слайд.</a:t>
             </a:r>
             <a:endParaRPr lang="en-US" dirty="0"/>
           </a:p>
@@ -7610,12 +7610,12 @@
         </p:nvSpPr>
         <p:spPr>
           <a:xfrm>
-            <a:off x="502920" y="1783080"/>
-            <a:ext cx="4685386" cy="960120"/>
+            <a:off x="502920" y="1572768"/>
+            <a:ext cx="3572256" cy="658368"/>
           </a:xfrm>
           <a:prstGeom prst="roundRect">
             <a:avLst>
-              <a:gd name="adj" fmla="val 6667"/>
+              <a:gd name="adj" fmla="val 9722"/>
             </a:avLst>
           </a:prstGeom>
           <a:solidFill>
@@ -7637,67 +7637,45 @@
         </p:nvSpPr>
         <p:spPr>
           <a:xfrm>
-            <a:off x="722376" y="1892808"/>
-            <a:ext cx="4246474" cy="292608"/>
-          </a:xfrm>
-          <a:prstGeom prst="rect">
-            <a:avLst/>
-          </a:prstGeom>
-          <a:noFill/>
-          <a:ln/>
-        </p:spPr>
-        <p:txBody>
-          <a:bodyPr wrap="square" lIns="0" tIns="0" rIns="0" bIns="0" rtlCol="0" anchor="t"/>
-          <a:lstStyle/>
-          <a:p>
-            <a:pPr indent="0" marL="0">
-              <a:buNone/>
-            </a:pPr>
-            <a:r>
-              <a:rPr lang="en-US" sz="1350" b="1" dirty="0">
-                <a:solidFill>
-                  <a:srgbClr val="13223B"/>
-                </a:solidFill>
-                <a:latin typeface="Calibri" pitchFamily="34" charset="0"/>
-                <a:ea typeface="Calibri" pitchFamily="34" charset="-122"/>
-                <a:cs typeface="Calibri" pitchFamily="34" charset="-120"/>
-              </a:rPr>
-              <a:t>Поток геолокации</a:t>
-            </a:r>
-            <a:endParaRPr lang="en-US" sz="1350" dirty="0"/>
-          </a:p>
-        </p:txBody>
-      </p:sp>
-      <p:sp>
-        <p:nvSpPr>
-          <p:cNvPr id="6" name="Text 4"/>
-          <p:cNvSpPr txBox="1"/>
-          <p:nvPr/>
-        </p:nvSpPr>
-        <p:spPr>
-          <a:xfrm>
-            <a:off x="722376" y="2203704"/>
-            <a:ext cx="4246474" cy="475488"/>
-          </a:xfrm>
-          <a:prstGeom prst="rect">
-            <a:avLst/>
-          </a:prstGeom>
-          <a:noFill/>
-          <a:ln/>
-        </p:spPr>
-        <p:txBody>
-          <a:bodyPr wrap="square" lIns="0" tIns="0" rIns="0" bIns="0" rtlCol="0" anchor="t">
+            <a:off x="667512" y="1572768"/>
+            <a:ext cx="3243072" cy="658368"/>
+          </a:xfrm>
+          <a:prstGeom prst="rect">
+            <a:avLst/>
+          </a:prstGeom>
+          <a:noFill/>
+          <a:ln/>
+        </p:spPr>
+        <p:txBody>
+          <a:bodyPr wrap="square" lIns="0" tIns="0" rIns="0" bIns="0" rtlCol="0" anchor="ctr">
             <a:normAutofit/>
           </a:bodyPr>
           <a:lstStyle/>
           <a:p>
             <a:pPr indent="0" marL="0">
               <a:lnSpc>
-                <a:spcPct val="115000"/>
+                <a:spcPct val="110000"/>
               </a:lnSpc>
               <a:buNone/>
             </a:pPr>
             <a:r>
+              <a:rPr lang="en-US" sz="1250" b="1" dirty="0">
+                <a:solidFill>
+                  <a:srgbClr val="13223B"/>
+                </a:solidFill>
+                <a:latin typeface="Calibri" pitchFamily="34" charset="0"/>
+                <a:ea typeface="Calibri" pitchFamily="34" charset="-122"/>
+                <a:cs typeface="Calibri" pitchFamily="34" charset="-120"/>
+              </a:rPr>
+              <a:t>Поток геолокации  </a:t>
+            </a:r>
+            <a:pPr indent="0" marL="0">
+              <a:lnSpc>
+                <a:spcPct val="110000"/>
+              </a:lnSpc>
+              <a:buNone/>
+            </a:pPr>
+            <a:r>
               <a:rPr lang="en-US" sz="1050" dirty="0">
                 <a:solidFill>
                   <a:srgbClr val="566173"/>
@@ -7706,26 +7684,26 @@
                 <a:ea typeface="Calibri" pitchFamily="34" charset="-122"/>
                 <a:cs typeface="Calibri" pitchFamily="34" charset="-120"/>
               </a:rPr>
-              <a:t>модуль реального времени, 2 источника, 5 целевых таблиц</a:t>
-            </a:r>
-            <a:endParaRPr lang="en-US" sz="1050" dirty="0"/>
-          </a:p>
-        </p:txBody>
-      </p:sp>
-      <p:sp>
-        <p:nvSpPr>
-          <p:cNvPr id="7" name="Shape 5"/>
+              <a:t>· модуль реального времени</a:t>
+            </a:r>
+            <a:endParaRPr lang="en-US" sz="1250" dirty="0"/>
+          </a:p>
+        </p:txBody>
+      </p:sp>
+      <p:sp>
+        <p:nvSpPr>
+          <p:cNvPr id="6" name="Shape 4"/>
           <p:cNvSpPr/>
           <p:nvPr/>
         </p:nvSpPr>
         <p:spPr>
           <a:xfrm>
-            <a:off x="502920" y="2880360"/>
-            <a:ext cx="4685386" cy="960120"/>
+            <a:off x="4294632" y="1572768"/>
+            <a:ext cx="3572256" cy="658368"/>
           </a:xfrm>
           <a:prstGeom prst="roundRect">
             <a:avLst>
-              <a:gd name="adj" fmla="val 6667"/>
+              <a:gd name="adj" fmla="val 9722"/>
             </a:avLst>
           </a:prstGeom>
           <a:solidFill>
@@ -7741,73 +7719,51 @@
       </p:sp>
       <p:sp>
         <p:nvSpPr>
-          <p:cNvPr id="8" name="Text 6"/>
-          <p:cNvSpPr txBox="1"/>
-          <p:nvPr/>
-        </p:nvSpPr>
-        <p:spPr>
-          <a:xfrm>
-            <a:off x="722376" y="2990088"/>
-            <a:ext cx="4246474" cy="292608"/>
-          </a:xfrm>
-          <a:prstGeom prst="rect">
-            <a:avLst/>
-          </a:prstGeom>
-          <a:noFill/>
-          <a:ln/>
-        </p:spPr>
-        <p:txBody>
-          <a:bodyPr wrap="square" lIns="0" tIns="0" rIns="0" bIns="0" rtlCol="0" anchor="t"/>
-          <a:lstStyle/>
-          <a:p>
-            <a:pPr indent="0" marL="0">
-              <a:buNone/>
-            </a:pPr>
-            <a:r>
-              <a:rPr lang="en-US" sz="1350" b="1" dirty="0">
-                <a:solidFill>
-                  <a:srgbClr val="13223B"/>
-                </a:solidFill>
-                <a:latin typeface="Calibri" pitchFamily="34" charset="0"/>
-                <a:ea typeface="Calibri" pitchFamily="34" charset="-122"/>
-                <a:cs typeface="Calibri" pitchFamily="34" charset="-120"/>
-              </a:rPr>
-              <a:t>Поток CDR</a:t>
-            </a:r>
-            <a:endParaRPr lang="en-US" sz="1350" dirty="0"/>
-          </a:p>
-        </p:txBody>
-      </p:sp>
-      <p:sp>
-        <p:nvSpPr>
-          <p:cNvPr id="9" name="Text 7"/>
-          <p:cNvSpPr txBox="1"/>
-          <p:nvPr/>
-        </p:nvSpPr>
-        <p:spPr>
-          <a:xfrm>
-            <a:off x="722376" y="3300984"/>
-            <a:ext cx="4246474" cy="475488"/>
-          </a:xfrm>
-          <a:prstGeom prst="rect">
-            <a:avLst/>
-          </a:prstGeom>
-          <a:noFill/>
-          <a:ln/>
-        </p:spPr>
-        <p:txBody>
-          <a:bodyPr wrap="square" lIns="0" tIns="0" rIns="0" bIns="0" rtlCol="0" anchor="t">
+          <p:cNvPr id="7" name="Text 5"/>
+          <p:cNvSpPr txBox="1"/>
+          <p:nvPr/>
+        </p:nvSpPr>
+        <p:spPr>
+          <a:xfrm>
+            <a:off x="4459224" y="1572768"/>
+            <a:ext cx="3243072" cy="658368"/>
+          </a:xfrm>
+          <a:prstGeom prst="rect">
+            <a:avLst/>
+          </a:prstGeom>
+          <a:noFill/>
+          <a:ln/>
+        </p:spPr>
+        <p:txBody>
+          <a:bodyPr wrap="square" lIns="0" tIns="0" rIns="0" bIns="0" rtlCol="0" anchor="ctr">
             <a:normAutofit/>
           </a:bodyPr>
           <a:lstStyle/>
           <a:p>
             <a:pPr indent="0" marL="0">
               <a:lnSpc>
-                <a:spcPct val="115000"/>
+                <a:spcPct val="110000"/>
               </a:lnSpc>
               <a:buNone/>
             </a:pPr>
             <a:r>
+              <a:rPr lang="en-US" sz="1250" b="1" dirty="0">
+                <a:solidFill>
+                  <a:srgbClr val="13223B"/>
+                </a:solidFill>
+                <a:latin typeface="Calibri" pitchFamily="34" charset="0"/>
+                <a:ea typeface="Calibri" pitchFamily="34" charset="-122"/>
+                <a:cs typeface="Calibri" pitchFamily="34" charset="-120"/>
+              </a:rPr>
+              <a:t>Поток CDR  </a:t>
+            </a:r>
+            <a:pPr indent="0" marL="0">
+              <a:lnSpc>
+                <a:spcPct val="110000"/>
+              </a:lnSpc>
+              <a:buNone/>
+            </a:pPr>
+            <a:r>
               <a:rPr lang="en-US" sz="1050" dirty="0">
                 <a:solidFill>
                   <a:srgbClr val="566173"/>
@@ -7816,26 +7772,26 @@
                 <a:ea typeface="Calibri" pitchFamily="34" charset="-122"/>
                 <a:cs typeface="Calibri" pitchFamily="34" charset="-120"/>
               </a:rPr>
-              <a:t>prepaid-звонки/SMS, фильтрация и коррекция часового пояса</a:t>
-            </a:r>
-            <a:endParaRPr lang="en-US" sz="1050" dirty="0"/>
-          </a:p>
-        </p:txBody>
-      </p:sp>
-      <p:sp>
-        <p:nvSpPr>
-          <p:cNvPr id="10" name="Shape 8"/>
+              <a:t>· prepaid-звонки и SMS</a:t>
+            </a:r>
+            <a:endParaRPr lang="en-US" sz="1250" dirty="0"/>
+          </a:p>
+        </p:txBody>
+      </p:sp>
+      <p:sp>
+        <p:nvSpPr>
+          <p:cNvPr id="8" name="Shape 6"/>
           <p:cNvSpPr/>
           <p:nvPr/>
         </p:nvSpPr>
         <p:spPr>
           <a:xfrm>
-            <a:off x="502920" y="3977640"/>
-            <a:ext cx="4685386" cy="960120"/>
+            <a:off x="8086344" y="1572768"/>
+            <a:ext cx="3572256" cy="658368"/>
           </a:xfrm>
           <a:prstGeom prst="roundRect">
             <a:avLst>
-              <a:gd name="adj" fmla="val 6667"/>
+              <a:gd name="adj" fmla="val 9722"/>
             </a:avLst>
           </a:prstGeom>
           <a:solidFill>
@@ -7851,30 +7807,35 @@
       </p:sp>
       <p:sp>
         <p:nvSpPr>
-          <p:cNvPr id="11" name="Text 9"/>
-          <p:cNvSpPr txBox="1"/>
-          <p:nvPr/>
-        </p:nvSpPr>
-        <p:spPr>
-          <a:xfrm>
-            <a:off x="722376" y="4087368"/>
-            <a:ext cx="4246474" cy="292608"/>
-          </a:xfrm>
-          <a:prstGeom prst="rect">
-            <a:avLst/>
-          </a:prstGeom>
-          <a:noFill/>
-          <a:ln/>
-        </p:spPr>
-        <p:txBody>
-          <a:bodyPr wrap="square" lIns="0" tIns="0" rIns="0" bIns="0" rtlCol="0" anchor="t"/>
-          <a:lstStyle/>
-          <a:p>
-            <a:pPr indent="0" marL="0">
-              <a:buNone/>
-            </a:pPr>
-            <a:r>
-              <a:rPr lang="en-US" sz="1350" b="1" dirty="0">
+          <p:cNvPr id="9" name="Text 7"/>
+          <p:cNvSpPr txBox="1"/>
+          <p:nvPr/>
+        </p:nvSpPr>
+        <p:spPr>
+          <a:xfrm>
+            <a:off x="8250936" y="1572768"/>
+            <a:ext cx="3243072" cy="658368"/>
+          </a:xfrm>
+          <a:prstGeom prst="rect">
+            <a:avLst/>
+          </a:prstGeom>
+          <a:noFill/>
+          <a:ln/>
+        </p:spPr>
+        <p:txBody>
+          <a:bodyPr wrap="square" lIns="0" tIns="0" rIns="0" bIns="0" rtlCol="0" anchor="ctr">
+            <a:normAutofit/>
+          </a:bodyPr>
+          <a:lstStyle/>
+          <a:p>
+            <a:pPr indent="0" marL="0">
+              <a:lnSpc>
+                <a:spcPct val="110000"/>
+              </a:lnSpc>
+              <a:buNone/>
+            </a:pPr>
+            <a:r>
+              <a:rPr lang="en-US" sz="1250" b="1" dirty="0">
                 <a:solidFill>
                   <a:srgbClr val="13223B"/>
                 </a:solidFill>
@@ -7882,22 +7843,39 @@
                 <a:ea typeface="Calibri" pitchFamily="34" charset="-122"/>
                 <a:cs typeface="Calibri" pitchFamily="34" charset="-120"/>
               </a:rPr>
-              <a:t>Витрина-агрегат</a:t>
-            </a:r>
-            <a:endParaRPr lang="en-US" sz="1350" dirty="0"/>
-          </a:p>
-        </p:txBody>
-      </p:sp>
-      <p:sp>
-        <p:nvSpPr>
-          <p:cNvPr id="12" name="Text 10"/>
-          <p:cNvSpPr txBox="1"/>
-          <p:nvPr/>
-        </p:nvSpPr>
-        <p:spPr>
-          <a:xfrm>
-            <a:off x="722376" y="4398264"/>
-            <a:ext cx="4246474" cy="475488"/>
+              <a:t>Витрина-агрегат  </a:t>
+            </a:r>
+            <a:pPr indent="0" marL="0">
+              <a:lnSpc>
+                <a:spcPct val="110000"/>
+              </a:lnSpc>
+              <a:buNone/>
+            </a:pPr>
+            <a:r>
+              <a:rPr lang="en-US" sz="1050" dirty="0">
+                <a:solidFill>
+                  <a:srgbClr val="566173"/>
+                </a:solidFill>
+                <a:latin typeface="Calibri" pitchFamily="34" charset="0"/>
+                <a:ea typeface="Calibri" pitchFamily="34" charset="-122"/>
+                <a:cs typeface="Calibri" pitchFamily="34" charset="-120"/>
+              </a:rPr>
+              <a:t>· образец финального теста</a:t>
+            </a:r>
+            <a:endParaRPr lang="en-US" sz="1250" dirty="0"/>
+          </a:p>
+        </p:txBody>
+      </p:sp>
+      <p:sp>
+        <p:nvSpPr>
+          <p:cNvPr id="10" name="Text 8"/>
+          <p:cNvSpPr txBox="1"/>
+          <p:nvPr/>
+        </p:nvSpPr>
+        <p:spPr>
+          <a:xfrm>
+            <a:off x="502920" y="2340864"/>
+            <a:ext cx="11155680" cy="384048"/>
           </a:xfrm>
           <a:prstGeom prst="rect">
             <a:avLst/>
@@ -7918,7 +7896,7 @@
               <a:buNone/>
             </a:pPr>
             <a:r>
-              <a:rPr lang="en-US" sz="1050" dirty="0">
+              <a:rPr lang="en-US" sz="1150" dirty="0">
                 <a:solidFill>
                   <a:srgbClr val="566173"/>
                 </a:solidFill>
@@ -7926,137 +7904,37 @@
                 <a:ea typeface="Calibri" pitchFamily="34" charset="-122"/>
                 <a:cs typeface="Calibri" pitchFamily="34" charset="-120"/>
               </a:rPr>
-              <a:t>ежемесячная сводка по устройствам — образец финального теста</a:t>
-            </a:r>
-            <a:endParaRPr lang="en-US" sz="1050" dirty="0"/>
-          </a:p>
-        </p:txBody>
-      </p:sp>
-      <p:sp>
-        <p:nvSpPr>
-          <p:cNvPr id="13" name="Shape 11"/>
+              <a:t>2 режима — офлайн (эвристики + покрытие шаблона) и живая LLM (Google Gemini 2.5 Flash), оба без сбоев. Ниже — настоящий вывод инструмента (офлайн-режим).</a:t>
+            </a:r>
+            <a:endParaRPr lang="en-US" sz="1150" dirty="0"/>
+          </a:p>
+        </p:txBody>
+      </p:sp>
+      <p:sp>
+        <p:nvSpPr>
+          <p:cNvPr id="11" name="Shape 9"/>
           <p:cNvSpPr/>
           <p:nvPr/>
         </p:nvSpPr>
         <p:spPr>
           <a:xfrm>
-            <a:off x="502920" y="5120640"/>
-            <a:ext cx="4685386" cy="1600200"/>
+            <a:off x="2503474" y="2825496"/>
+            <a:ext cx="7154571" cy="3721608"/>
           </a:xfrm>
           <a:prstGeom prst="roundRect">
             <a:avLst>
-              <a:gd name="adj" fmla="val 4571"/>
+              <a:gd name="adj" fmla="val 1474"/>
             </a:avLst>
           </a:prstGeom>
           <a:solidFill>
-            <a:srgbClr val="13223B"/>
+            <a:srgbClr val="FFFFFF"/>
           </a:solidFill>
-          <a:ln/>
-        </p:spPr>
-      </p:sp>
-      <p:sp>
-        <p:nvSpPr>
-          <p:cNvPr id="14" name="Text 12"/>
-          <p:cNvSpPr txBox="1"/>
-          <p:nvPr/>
-        </p:nvSpPr>
-        <p:spPr>
-          <a:xfrm>
-            <a:off x="740664" y="5312664"/>
-            <a:ext cx="4209898" cy="274320"/>
-          </a:xfrm>
-          <a:prstGeom prst="rect">
-            <a:avLst/>
-          </a:prstGeom>
-          <a:noFill/>
-          <a:ln/>
-        </p:spPr>
-        <p:txBody>
-          <a:bodyPr wrap="square" lIns="0" tIns="0" rIns="0" bIns="0" rtlCol="0" anchor="t"/>
-          <a:lstStyle/>
-          <a:p>
-            <a:pPr indent="0" marL="0">
-              <a:buNone/>
-            </a:pPr>
-            <a:r>
-              <a:rPr lang="en-US" sz="1100" b="1" spc="100" kern="0" dirty="0">
-                <a:solidFill>
-                  <a:srgbClr val="D98324"/>
-                </a:solidFill>
-                <a:latin typeface="Calibri" pitchFamily="34" charset="0"/>
-                <a:ea typeface="Calibri" pitchFamily="34" charset="-122"/>
-                <a:cs typeface="Calibri" pitchFamily="34" charset="-120"/>
-              </a:rPr>
-              <a:t>2 РЕЖИМА, ОБА БЕЗ СБОЕВ</a:t>
-            </a:r>
-            <a:endParaRPr lang="en-US" sz="1100" dirty="0"/>
-          </a:p>
-        </p:txBody>
-      </p:sp>
-      <p:sp>
-        <p:nvSpPr>
-          <p:cNvPr id="15" name="Text 13"/>
-          <p:cNvSpPr txBox="1"/>
-          <p:nvPr/>
-        </p:nvSpPr>
-        <p:spPr>
-          <a:xfrm>
-            <a:off x="740664" y="5623560"/>
-            <a:ext cx="4209898" cy="1005840"/>
-          </a:xfrm>
-          <a:prstGeom prst="rect">
-            <a:avLst/>
-          </a:prstGeom>
-          <a:noFill/>
-          <a:ln/>
-        </p:spPr>
-        <p:txBody>
-          <a:bodyPr wrap="square" lIns="0" tIns="0" rIns="0" bIns="0" rtlCol="0" anchor="t">
-            <a:normAutofit/>
-          </a:bodyPr>
-          <a:lstStyle/>
-          <a:p>
-            <a:pPr indent="0" marL="0">
-              <a:lnSpc>
-                <a:spcPct val="128000"/>
-              </a:lnSpc>
-              <a:buNone/>
-            </a:pPr>
-            <a:r>
-              <a:rPr lang="en-US" sz="1150" dirty="0">
-                <a:solidFill>
-                  <a:srgbClr val="D6DFEC"/>
-                </a:solidFill>
-                <a:latin typeface="Calibri" pitchFamily="34" charset="0"/>
-                <a:ea typeface="Calibri" pitchFamily="34" charset="-122"/>
-                <a:cs typeface="Calibri" pitchFamily="34" charset="-120"/>
-              </a:rPr>
-              <a:t>Офлайн (эвристики + покрытие шаблона) и живая LLM — Google Gemini 2.5 Flash через OpenAI-совместимый эндпоинт, без единой правки кода.</a:t>
-            </a:r>
-            <a:endParaRPr lang="en-US" sz="1150" dirty="0"/>
-          </a:p>
-        </p:txBody>
-      </p:sp>
-      <p:sp>
-        <p:nvSpPr>
-          <p:cNvPr id="16" name="Shape 14"/>
-          <p:cNvSpPr/>
-          <p:nvPr/>
-        </p:nvSpPr>
-        <p:spPr>
-          <a:xfrm>
-            <a:off x="5453482" y="1728216"/>
-            <a:ext cx="2354164" cy="4224528"/>
-          </a:xfrm>
-          <a:prstGeom prst="roundRect">
-            <a:avLst>
-              <a:gd name="adj" fmla="val 2331"/>
-            </a:avLst>
-          </a:prstGeom>
-          <a:solidFill>
-            <a:srgbClr val="13223B"/>
-          </a:solidFill>
-          <a:ln/>
+          <a:ln w="12700">
+            <a:solidFill>
+              <a:srgbClr val="D4DCE6"/>
+            </a:solidFill>
+            <a:prstDash val="solid"/>
+          </a:ln>
           <a:effectLst>
             <a:outerShdw sx="100000" sy="100000" kx="0" ky="0" algn="bl" rotWithShape="0" blurRad="114300" dist="38100" dir="5400000">
               <a:srgbClr val="AAB4C0">
@@ -8068,7 +7946,7 @@
       </p:sp>
       <p:pic>
         <p:nvPicPr>
-          <p:cNvPr id="17" name="Image 0" descr="C:\Masaüstü\tz-reviewer\presentation\assets\real-output.png">    </p:cNvPr>
+          <p:cNvPr id="12" name="Image 0" descr="C:\Masaüstü\tz-reviewer\presentation\assets\real-output.png">    </p:cNvPr>
           <p:cNvPicPr>
             <a:picLocks noChangeAspect="1"/>
           </p:cNvPicPr>
@@ -8082,58 +7960,14 @@
         </p:blipFill>
         <p:spPr>
           <a:xfrm>
-            <a:off x="5508346" y="1783080"/>
-            <a:ext cx="2244436" cy="4114800"/>
+            <a:off x="2558338" y="2880360"/>
+            <a:ext cx="7044843" cy="3611880"/>
           </a:xfrm>
           <a:prstGeom prst="rect">
             <a:avLst/>
           </a:prstGeom>
         </p:spPr>
       </p:pic>
-      <p:sp>
-        <p:nvSpPr>
-          <p:cNvPr id="18" name="Text 15"/>
-          <p:cNvSpPr txBox="1"/>
-          <p:nvPr/>
-        </p:nvSpPr>
-        <p:spPr>
-          <a:xfrm>
-            <a:off x="5508346" y="6044184"/>
-            <a:ext cx="2377440" cy="502920"/>
-          </a:xfrm>
-          <a:prstGeom prst="rect">
-            <a:avLst/>
-          </a:prstGeom>
-          <a:noFill/>
-          <a:ln/>
-        </p:spPr>
-        <p:txBody>
-          <a:bodyPr wrap="square" lIns="0" tIns="0" rIns="0" bIns="0" rtlCol="0" anchor="t">
-            <a:normAutofit/>
-          </a:bodyPr>
-          <a:lstStyle/>
-          <a:p>
-            <a:pPr indent="0" marL="0">
-              <a:lnSpc>
-                <a:spcPct val="120000"/>
-              </a:lnSpc>
-              <a:buNone/>
-            </a:pPr>
-            <a:r>
-              <a:rPr lang="en-US" sz="1050" i="1" dirty="0">
-                <a:solidFill>
-                  <a:srgbClr val="566173"/>
-                </a:solidFill>
-                <a:latin typeface="Calibri" pitchFamily="34" charset="0"/>
-                <a:ea typeface="Calibri" pitchFamily="34" charset="-122"/>
-                <a:cs typeface="Calibri" pitchFamily="34" charset="-120"/>
-              </a:rPr>
-              <a:t>Реальный вывод: офлайн-режим, поток геолокации (настоящий документ кейсодателя).</a:t>
-            </a:r>
-            <a:endParaRPr lang="en-US" sz="1050" dirty="0"/>
-          </a:p>
-        </p:txBody>
-      </p:sp>
     </p:spTree>
   </p:cSld>
   <p:clrMapOvr>

</xml_diff>